<commit_message>
feat(cheil): campaign OT, result report, media plan and contact report after the agency's own documents
The four field templates are rebuilt from the structure of the agency's
kickoff/production OT decks, campaign result reports, media briefs and
contact reports (structure only: every name and number is a blank).

- campaign OT: the brief becomes a 14-slide deck
- result report: 12 slides, quantitative and qualitative results
- media plan: overview, plan with CPM/CPV/CTR, budget by media type,
  creatives; the sheet fill now reads A1:L60
- contact report: header table, summary, feedback with quotes and AE
  notes, NEXT for both sides
- a campaign card fill into a workbook still streaming in retries instead
  of reporting nothing filled
- Word-based e2e flows move to the contact report and pitch analysis;
  e2e/cheil-templates-look.spec.ts opens the four and photographs them

Co-Authored-By: Claude Opus 5.5 <noreply@anthropic.com>
</commit_message>
<xml_diff>
--- a/apps/shell/resources/builtin-skills/cheil-proposal/assets/캠페인 제안서.pptx
+++ b/apps/shell/resources/builtin-skills/cheil-proposal/assets/캠페인 제안서.pptx
@@ -3237,13 +3237,19 @@
             <p:ph type="title"/>
           </p:nvPr>
         </p:nvSpPr>
-        <p:spPr/>
-        <p:txBody>
-          <a:bodyPr/>
-          <a:lstStyle/>
-          <a:p>
-            <a:r>
-              <a:rPr sz="2800" b="1">
+        <p:spPr>
+          <a:xfrm>
+            <a:off x="457200" y="560000"/>
+            <a:ext cx="11277600" cy="800000"/>
+          </a:xfrm>
+        </p:spPr>
+        <p:txBody>
+          <a:bodyPr/>
+          <a:lstStyle/>
+          <a:p>
+            <a:pPr algn="l"/>
+            <a:r>
+              <a:rPr sz="2400" b="1">
                 <a:solidFill>
                   <a:srgbClr val="1A1A1A"/>
                 </a:solidFill>
@@ -3818,13 +3824,19 @@
             <p:ph type="title"/>
           </p:nvPr>
         </p:nvSpPr>
-        <p:spPr/>
-        <p:txBody>
-          <a:bodyPr/>
-          <a:lstStyle/>
-          <a:p>
-            <a:r>
-              <a:rPr sz="2800" b="1">
+        <p:spPr>
+          <a:xfrm>
+            <a:off x="457200" y="560000"/>
+            <a:ext cx="11277600" cy="800000"/>
+          </a:xfrm>
+        </p:spPr>
+        <p:txBody>
+          <a:bodyPr/>
+          <a:lstStyle/>
+          <a:p>
+            <a:pPr algn="l"/>
+            <a:r>
+              <a:rPr sz="2400" b="1">
                 <a:solidFill>
                   <a:srgbClr val="1A1A1A"/>
                 </a:solidFill>
@@ -4370,13 +4382,19 @@
             <p:ph type="title"/>
           </p:nvPr>
         </p:nvSpPr>
-        <p:spPr/>
-        <p:txBody>
-          <a:bodyPr/>
-          <a:lstStyle/>
-          <a:p>
-            <a:r>
-              <a:rPr sz="2800" b="1">
+        <p:spPr>
+          <a:xfrm>
+            <a:off x="457200" y="560000"/>
+            <a:ext cx="11277600" cy="800000"/>
+          </a:xfrm>
+        </p:spPr>
+        <p:txBody>
+          <a:bodyPr/>
+          <a:lstStyle/>
+          <a:p>
+            <a:pPr algn="l"/>
+            <a:r>
+              <a:rPr sz="2400" b="1">
                 <a:solidFill>
                   <a:srgbClr val="1A1A1A"/>
                 </a:solidFill>
@@ -4397,7 +4415,12 @@
             <p:ph idx="1"/>
           </p:nvPr>
         </p:nvSpPr>
-        <p:spPr/>
+        <p:spPr>
+          <a:xfrm>
+            <a:off x="457200" y="1650000"/>
+            <a:ext cx="11277600" cy="4500000"/>
+          </a:xfrm>
+        </p:spPr>
         <p:txBody>
           <a:bodyPr/>
           <a:lstStyle/>
@@ -4573,13 +4596,19 @@
             <p:ph type="title"/>
           </p:nvPr>
         </p:nvSpPr>
-        <p:spPr/>
-        <p:txBody>
-          <a:bodyPr/>
-          <a:lstStyle/>
-          <a:p>
-            <a:r>
-              <a:rPr sz="2800" b="1">
+        <p:spPr>
+          <a:xfrm>
+            <a:off x="457200" y="560000"/>
+            <a:ext cx="11277600" cy="800000"/>
+          </a:xfrm>
+        </p:spPr>
+        <p:txBody>
+          <a:bodyPr/>
+          <a:lstStyle/>
+          <a:p>
+            <a:pPr algn="l"/>
+            <a:r>
+              <a:rPr sz="2400" b="1">
                 <a:solidFill>
                   <a:srgbClr val="1A1A1A"/>
                 </a:solidFill>
@@ -4600,7 +4629,12 @@
             <p:ph idx="1"/>
           </p:nvPr>
         </p:nvSpPr>
-        <p:spPr/>
+        <p:spPr>
+          <a:xfrm>
+            <a:off x="457200" y="1650000"/>
+            <a:ext cx="11277600" cy="4500000"/>
+          </a:xfrm>
+        </p:spPr>
         <p:txBody>
           <a:bodyPr/>
           <a:lstStyle/>
@@ -4716,13 +4750,19 @@
             <p:ph type="title"/>
           </p:nvPr>
         </p:nvSpPr>
-        <p:spPr/>
-        <p:txBody>
-          <a:bodyPr/>
-          <a:lstStyle/>
-          <a:p>
-            <a:r>
-              <a:rPr sz="2800" b="1">
+        <p:spPr>
+          <a:xfrm>
+            <a:off x="457200" y="560000"/>
+            <a:ext cx="11277600" cy="800000"/>
+          </a:xfrm>
+        </p:spPr>
+        <p:txBody>
+          <a:bodyPr/>
+          <a:lstStyle/>
+          <a:p>
+            <a:pPr algn="l"/>
+            <a:r>
+              <a:rPr sz="2400" b="1">
                 <a:solidFill>
                   <a:srgbClr val="1A1A1A"/>
                 </a:solidFill>
@@ -4743,7 +4783,12 @@
             <p:ph idx="1"/>
           </p:nvPr>
         </p:nvSpPr>
-        <p:spPr/>
+        <p:spPr>
+          <a:xfrm>
+            <a:off x="457200" y="1650000"/>
+            <a:ext cx="11277600" cy="4500000"/>
+          </a:xfrm>
+        </p:spPr>
         <p:txBody>
           <a:bodyPr/>
           <a:lstStyle/>
@@ -4859,13 +4904,19 @@
             <p:ph type="title"/>
           </p:nvPr>
         </p:nvSpPr>
-        <p:spPr/>
-        <p:txBody>
-          <a:bodyPr/>
-          <a:lstStyle/>
-          <a:p>
-            <a:r>
-              <a:rPr sz="2800" b="1">
+        <p:spPr>
+          <a:xfrm>
+            <a:off x="457200" y="560000"/>
+            <a:ext cx="11277600" cy="800000"/>
+          </a:xfrm>
+        </p:spPr>
+        <p:txBody>
+          <a:bodyPr/>
+          <a:lstStyle/>
+          <a:p>
+            <a:pPr algn="l"/>
+            <a:r>
+              <a:rPr sz="2400" b="1">
                 <a:solidFill>
                   <a:srgbClr val="1A1A1A"/>
                 </a:solidFill>
@@ -4886,7 +4937,12 @@
             <p:ph idx="1"/>
           </p:nvPr>
         </p:nvSpPr>
-        <p:spPr/>
+        <p:spPr>
+          <a:xfrm>
+            <a:off x="457200" y="1650000"/>
+            <a:ext cx="11277600" cy="4500000"/>
+          </a:xfrm>
+        </p:spPr>
         <p:txBody>
           <a:bodyPr/>
           <a:lstStyle/>
@@ -4990,13 +5046,19 @@
             <p:ph type="title"/>
           </p:nvPr>
         </p:nvSpPr>
-        <p:spPr/>
-        <p:txBody>
-          <a:bodyPr/>
-          <a:lstStyle/>
-          <a:p>
-            <a:r>
-              <a:rPr sz="2800" b="1">
+        <p:spPr>
+          <a:xfrm>
+            <a:off x="457200" y="560000"/>
+            <a:ext cx="11277600" cy="800000"/>
+          </a:xfrm>
+        </p:spPr>
+        <p:txBody>
+          <a:bodyPr/>
+          <a:lstStyle/>
+          <a:p>
+            <a:pPr algn="l"/>
+            <a:r>
+              <a:rPr sz="2400" b="1">
                 <a:solidFill>
                   <a:srgbClr val="1A1A1A"/>
                 </a:solidFill>
@@ -5017,7 +5079,12 @@
             <p:ph idx="1"/>
           </p:nvPr>
         </p:nvSpPr>
-        <p:spPr/>
+        <p:spPr>
+          <a:xfrm>
+            <a:off x="457200" y="1650000"/>
+            <a:ext cx="11277600" cy="4500000"/>
+          </a:xfrm>
+        </p:spPr>
         <p:txBody>
           <a:bodyPr/>
           <a:lstStyle/>
@@ -5133,13 +5200,19 @@
             <p:ph type="title"/>
           </p:nvPr>
         </p:nvSpPr>
-        <p:spPr/>
-        <p:txBody>
-          <a:bodyPr/>
-          <a:lstStyle/>
-          <a:p>
-            <a:r>
-              <a:rPr sz="2800" b="1">
+        <p:spPr>
+          <a:xfrm>
+            <a:off x="457200" y="560000"/>
+            <a:ext cx="11277600" cy="800000"/>
+          </a:xfrm>
+        </p:spPr>
+        <p:txBody>
+          <a:bodyPr/>
+          <a:lstStyle/>
+          <a:p>
+            <a:pPr algn="l"/>
+            <a:r>
+              <a:rPr sz="2400" b="1">
                 <a:solidFill>
                   <a:srgbClr val="1A1A1A"/>
                 </a:solidFill>
@@ -5160,7 +5233,12 @@
             <p:ph idx="1"/>
           </p:nvPr>
         </p:nvSpPr>
-        <p:spPr/>
+        <p:spPr>
+          <a:xfrm>
+            <a:off x="457200" y="1650000"/>
+            <a:ext cx="11277600" cy="4500000"/>
+          </a:xfrm>
+        </p:spPr>
         <p:txBody>
           <a:bodyPr/>
           <a:lstStyle/>
@@ -5252,13 +5330,19 @@
             <p:ph type="title"/>
           </p:nvPr>
         </p:nvSpPr>
-        <p:spPr/>
-        <p:txBody>
-          <a:bodyPr/>
-          <a:lstStyle/>
-          <a:p>
-            <a:r>
-              <a:rPr sz="2800" b="1">
+        <p:spPr>
+          <a:xfrm>
+            <a:off x="457200" y="560000"/>
+            <a:ext cx="11277600" cy="800000"/>
+          </a:xfrm>
+        </p:spPr>
+        <p:txBody>
+          <a:bodyPr/>
+          <a:lstStyle/>
+          <a:p>
+            <a:pPr algn="l"/>
+            <a:r>
+              <a:rPr sz="2400" b="1">
                 <a:solidFill>
                   <a:srgbClr val="1A1A1A"/>
                 </a:solidFill>
@@ -5279,7 +5363,12 @@
             <p:ph idx="1"/>
           </p:nvPr>
         </p:nvSpPr>
-        <p:spPr/>
+        <p:spPr>
+          <a:xfrm>
+            <a:off x="457200" y="1650000"/>
+            <a:ext cx="11277600" cy="4500000"/>
+          </a:xfrm>
+        </p:spPr>
         <p:txBody>
           <a:bodyPr/>
           <a:lstStyle/>
@@ -5383,13 +5472,19 @@
             <p:ph type="title"/>
           </p:nvPr>
         </p:nvSpPr>
-        <p:spPr/>
-        <p:txBody>
-          <a:bodyPr/>
-          <a:lstStyle/>
-          <a:p>
-            <a:r>
-              <a:rPr sz="2800" b="1">
+        <p:spPr>
+          <a:xfrm>
+            <a:off x="457200" y="560000"/>
+            <a:ext cx="11277600" cy="800000"/>
+          </a:xfrm>
+        </p:spPr>
+        <p:txBody>
+          <a:bodyPr/>
+          <a:lstStyle/>
+          <a:p>
+            <a:pPr algn="l"/>
+            <a:r>
+              <a:rPr sz="2400" b="1">
                 <a:solidFill>
                   <a:srgbClr val="1A1A1A"/>
                 </a:solidFill>

</xml_diff>